<commit_message>
Launch ready: remove all mock data, dynamic badges, real email reminders
</commit_message>
<xml_diff>
--- a/ArtistOS-PitchDeck.pptx
+++ b/ArtistOS-PitchDeck.pptx
@@ -6424,9 +6424,11 @@
                 <a:ea typeface="Georgia" pitchFamily="34" charset="-122"/>
                 <a:cs typeface="Georgia" pitchFamily="34" charset="-120"/>
               </a:rPr>
-              <a:t>Every artist deserves the tools
-</a:t>
-            </a:r>
+              <a:t>Every artist deserves the tools</a:t>
+            </a:r>
+            <a:endParaRPr lang="en-US" sz="2800" dirty="0"/>
+          </a:p>
+          <a:p>
             <a:pPr algn="ctr" indent="0" marL="0">
               <a:buNone/>
             </a:pPr>
@@ -6439,9 +6441,11 @@
                 <a:ea typeface="Georgia" pitchFamily="34" charset="-122"/>
                 <a:cs typeface="Georgia" pitchFamily="34" charset="-120"/>
               </a:rPr>
-              <a:t>to turn their passion into a
-</a:t>
-            </a:r>
+              <a:t>to turn their passion into a</a:t>
+            </a:r>
+            <a:endParaRPr lang="en-US" sz="2800" dirty="0"/>
+          </a:p>
+          <a:p>
             <a:pPr algn="ctr" indent="0" marL="0">
               <a:buNone/>
             </a:pPr>
@@ -7851,7 +7855,7 @@
       </p:sp>
       <p:sp>
         <p:nvSpPr>
-          <p:cNvPr id="8" name="Text 6"/>
+          <p:cNvPr id="8" name="Shape 6"/>
           <p:cNvSpPr/>
           <p:nvPr/>
         </p:nvSpPr>
@@ -7860,6 +7864,26 @@
             <a:off x="822960" y="2331720"/>
             <a:ext cx="548640" cy="548640"/>
           </a:xfrm>
+          <a:prstGeom prst="ellipse">
+            <a:avLst/>
+          </a:prstGeom>
+          <a:solidFill>
+            <a:srgbClr val="B5651D"/>
+          </a:solidFill>
+          <a:ln/>
+        </p:spPr>
+      </p:sp>
+      <p:sp>
+        <p:nvSpPr>
+          <p:cNvPr id="9" name="Text 7"/>
+          <p:cNvSpPr/>
+          <p:nvPr/>
+        </p:nvSpPr>
+        <p:spPr>
+          <a:xfrm>
+            <a:off x="822960" y="2331720"/>
+            <a:ext cx="548640" cy="548640"/>
+          </a:xfrm>
           <a:prstGeom prst="rect">
             <a:avLst/>
           </a:prstGeom>
@@ -7874,20 +7898,23 @@
               <a:buNone/>
             </a:pPr>
             <a:r>
-              <a:rPr lang="en-US" sz="2800" dirty="0">
-                <a:solidFill>
-                  <a:srgbClr val="000000"/>
-                </a:solidFill>
-              </a:rPr>
-              <a:t>🎨</a:t>
-            </a:r>
-            <a:endParaRPr lang="en-US" sz="2800" dirty="0"/>
-          </a:p>
-        </p:txBody>
-      </p:sp>
-      <p:sp>
-        <p:nvSpPr>
-          <p:cNvPr id="9" name="Text 7"/>
+              <a:rPr lang="en-US" sz="1800" b="1" dirty="0">
+                <a:solidFill>
+                  <a:srgbClr val="FAF8F5"/>
+                </a:solidFill>
+                <a:latin typeface="Calibri" pitchFamily="34" charset="0"/>
+                <a:ea typeface="Calibri" pitchFamily="34" charset="-122"/>
+                <a:cs typeface="Calibri" pitchFamily="34" charset="-120"/>
+              </a:rPr>
+              <a:t>P</a:t>
+            </a:r>
+            <a:endParaRPr lang="en-US" sz="1800" dirty="0"/>
+          </a:p>
+        </p:txBody>
+      </p:sp>
+      <p:sp>
+        <p:nvSpPr>
+          <p:cNvPr id="10" name="Text 8"/>
           <p:cNvSpPr/>
           <p:nvPr/>
         </p:nvSpPr>
@@ -7926,7 +7953,7 @@
       </p:sp>
       <p:sp>
         <p:nvSpPr>
-          <p:cNvPr id="10" name="Text 8"/>
+          <p:cNvPr id="11" name="Text 9"/>
           <p:cNvSpPr/>
           <p:nvPr/>
         </p:nvSpPr>
@@ -7965,7 +7992,7 @@
       </p:sp>
       <p:sp>
         <p:nvSpPr>
-          <p:cNvPr id="11" name="Shape 9"/>
+          <p:cNvPr id="12" name="Shape 10"/>
           <p:cNvSpPr/>
           <p:nvPr/>
         </p:nvSpPr>
@@ -7992,7 +8019,7 @@
       </p:sp>
       <p:sp>
         <p:nvSpPr>
-          <p:cNvPr id="12" name="Shape 10"/>
+          <p:cNvPr id="13" name="Shape 11"/>
           <p:cNvSpPr/>
           <p:nvPr/>
         </p:nvSpPr>
@@ -8012,7 +8039,7 @@
       </p:sp>
       <p:sp>
         <p:nvSpPr>
-          <p:cNvPr id="13" name="Text 11"/>
+          <p:cNvPr id="14" name="Shape 12"/>
           <p:cNvSpPr/>
           <p:nvPr/>
         </p:nvSpPr>
@@ -8021,6 +8048,26 @@
             <a:off x="3611880" y="2331720"/>
             <a:ext cx="548640" cy="548640"/>
           </a:xfrm>
+          <a:prstGeom prst="ellipse">
+            <a:avLst/>
+          </a:prstGeom>
+          <a:solidFill>
+            <a:srgbClr val="B5651D"/>
+          </a:solidFill>
+          <a:ln/>
+        </p:spPr>
+      </p:sp>
+      <p:sp>
+        <p:nvSpPr>
+          <p:cNvPr id="15" name="Text 13"/>
+          <p:cNvSpPr/>
+          <p:nvPr/>
+        </p:nvSpPr>
+        <p:spPr>
+          <a:xfrm>
+            <a:off x="3611880" y="2331720"/>
+            <a:ext cx="548640" cy="548640"/>
+          </a:xfrm>
           <a:prstGeom prst="rect">
             <a:avLst/>
           </a:prstGeom>
@@ -8035,20 +8082,23 @@
               <a:buNone/>
             </a:pPr>
             <a:r>
-              <a:rPr lang="en-US" sz="2800" dirty="0">
-                <a:solidFill>
-                  <a:srgbClr val="000000"/>
-                </a:solidFill>
-              </a:rPr>
-              <a:t>💰</a:t>
-            </a:r>
-            <a:endParaRPr lang="en-US" sz="2800" dirty="0"/>
-          </a:p>
-        </p:txBody>
-      </p:sp>
-      <p:sp>
-        <p:nvSpPr>
-          <p:cNvPr id="14" name="Text 12"/>
+              <a:rPr lang="en-US" sz="1800" b="1" dirty="0">
+                <a:solidFill>
+                  <a:srgbClr val="FAF8F5"/>
+                </a:solidFill>
+                <a:latin typeface="Calibri" pitchFamily="34" charset="0"/>
+                <a:ea typeface="Calibri" pitchFamily="34" charset="-122"/>
+                <a:cs typeface="Calibri" pitchFamily="34" charset="-120"/>
+              </a:rPr>
+              <a:t>$</a:t>
+            </a:r>
+            <a:endParaRPr lang="en-US" sz="1800" dirty="0"/>
+          </a:p>
+        </p:txBody>
+      </p:sp>
+      <p:sp>
+        <p:nvSpPr>
+          <p:cNvPr id="16" name="Text 14"/>
           <p:cNvSpPr/>
           <p:nvPr/>
         </p:nvSpPr>
@@ -8087,7 +8137,7 @@
       </p:sp>
       <p:sp>
         <p:nvSpPr>
-          <p:cNvPr id="15" name="Text 13"/>
+          <p:cNvPr id="17" name="Text 15"/>
           <p:cNvSpPr/>
           <p:nvPr/>
         </p:nvSpPr>
@@ -8126,7 +8176,7 @@
       </p:sp>
       <p:sp>
         <p:nvSpPr>
-          <p:cNvPr id="16" name="Shape 14"/>
+          <p:cNvPr id="18" name="Shape 16"/>
           <p:cNvSpPr/>
           <p:nvPr/>
         </p:nvSpPr>
@@ -8153,7 +8203,7 @@
       </p:sp>
       <p:sp>
         <p:nvSpPr>
-          <p:cNvPr id="17" name="Shape 15"/>
+          <p:cNvPr id="19" name="Shape 17"/>
           <p:cNvSpPr/>
           <p:nvPr/>
         </p:nvSpPr>
@@ -8173,7 +8223,7 @@
       </p:sp>
       <p:sp>
         <p:nvSpPr>
-          <p:cNvPr id="18" name="Text 16"/>
+          <p:cNvPr id="20" name="Shape 18"/>
           <p:cNvSpPr/>
           <p:nvPr/>
         </p:nvSpPr>
@@ -8182,6 +8232,26 @@
             <a:off x="6400800" y="2331720"/>
             <a:ext cx="548640" cy="548640"/>
           </a:xfrm>
+          <a:prstGeom prst="ellipse">
+            <a:avLst/>
+          </a:prstGeom>
+          <a:solidFill>
+            <a:srgbClr val="B5651D"/>
+          </a:solidFill>
+          <a:ln/>
+        </p:spPr>
+      </p:sp>
+      <p:sp>
+        <p:nvSpPr>
+          <p:cNvPr id="21" name="Text 19"/>
+          <p:cNvSpPr/>
+          <p:nvPr/>
+        </p:nvSpPr>
+        <p:spPr>
+          <a:xfrm>
+            <a:off x="6400800" y="2331720"/>
+            <a:ext cx="548640" cy="548640"/>
+          </a:xfrm>
           <a:prstGeom prst="rect">
             <a:avLst/>
           </a:prstGeom>
@@ -8196,20 +8266,23 @@
               <a:buNone/>
             </a:pPr>
             <a:r>
-              <a:rPr lang="en-US" sz="2800" dirty="0">
-                <a:solidFill>
-                  <a:srgbClr val="000000"/>
-                </a:solidFill>
-              </a:rPr>
-              <a:t>🤖</a:t>
-            </a:r>
-            <a:endParaRPr lang="en-US" sz="2800" dirty="0"/>
-          </a:p>
-        </p:txBody>
-      </p:sp>
-      <p:sp>
-        <p:nvSpPr>
-          <p:cNvPr id="19" name="Text 17"/>
+              <a:rPr lang="en-US" sz="1800" b="1" dirty="0">
+                <a:solidFill>
+                  <a:srgbClr val="FAF8F5"/>
+                </a:solidFill>
+                <a:latin typeface="Calibri" pitchFamily="34" charset="0"/>
+                <a:ea typeface="Calibri" pitchFamily="34" charset="-122"/>
+                <a:cs typeface="Calibri" pitchFamily="34" charset="-120"/>
+              </a:rPr>
+              <a:t>AI</a:t>
+            </a:r>
+            <a:endParaRPr lang="en-US" sz="1800" dirty="0"/>
+          </a:p>
+        </p:txBody>
+      </p:sp>
+      <p:sp>
+        <p:nvSpPr>
+          <p:cNvPr id="22" name="Text 20"/>
           <p:cNvSpPr/>
           <p:nvPr/>
         </p:nvSpPr>
@@ -8248,7 +8321,7 @@
       </p:sp>
       <p:sp>
         <p:nvSpPr>
-          <p:cNvPr id="20" name="Text 18"/>
+          <p:cNvPr id="23" name="Text 21"/>
           <p:cNvSpPr/>
           <p:nvPr/>
         </p:nvSpPr>
@@ -11707,23 +11780,42 @@
       </p:sp>
       <p:sp>
         <p:nvSpPr>
-          <p:cNvPr id="25" name="Shape 23"/>
-          <p:cNvSpPr/>
-          <p:nvPr/>
-        </p:nvSpPr>
-        <p:spPr>
-          <a:xfrm>
-            <a:off x="640080" y="4800600"/>
-            <a:ext cx="7863840" cy="0"/>
-          </a:xfrm>
-          <a:prstGeom prst="rect">
-            <a:avLst/>
-          </a:prstGeom>
-          <a:solidFill>
-            <a:srgbClr val="F2EDE6"/>
-          </a:solidFill>
-          <a:ln/>
-        </p:spPr>
+          <p:cNvPr id="25" name="Text 23"/>
+          <p:cNvSpPr/>
+          <p:nvPr/>
+        </p:nvSpPr>
+        <p:spPr>
+          <a:xfrm>
+            <a:off x="640080" y="4709160"/>
+            <a:ext cx="7863840" cy="274320"/>
+          </a:xfrm>
+          <a:prstGeom prst="rect">
+            <a:avLst/>
+          </a:prstGeom>
+          <a:noFill/>
+          <a:ln/>
+        </p:spPr>
+        <p:txBody>
+          <a:bodyPr wrap="square" lIns="0" tIns="0" rIns="0" bIns="0" rtlCol="0" anchor="ctr"/>
+          <a:lstStyle/>
+          <a:p>
+            <a:pPr algn="ctr" indent="0" marL="0">
+              <a:buNone/>
+            </a:pPr>
+            <a:r>
+              <a:rPr lang="en-US" sz="1000" dirty="0">
+                <a:solidFill>
+                  <a:srgbClr val="A89F94"/>
+                </a:solidFill>
+                <a:latin typeface="Calibri" pitchFamily="34" charset="0"/>
+                <a:ea typeface="Calibri" pitchFamily="34" charset="-122"/>
+                <a:cs typeface="Calibri" pitchFamily="34" charset="-120"/>
+              </a:rPr>
+              <a:t>Future: Marketplace transaction fees (5–8%) • Premium AI features</a:t>
+            </a:r>
+            <a:endParaRPr lang="en-US" sz="1000" dirty="0"/>
+          </a:p>
+        </p:txBody>
       </p:sp>
     </p:spTree>
   </p:cSld>

</xml_diff>